<commit_message>
breve atualização nas apresentações.
</commit_message>
<xml_diff>
--- a/apresentacoes/0.2_simposio-cd.pptx
+++ b/apresentacoes/0.2_simposio-cd.pptx
@@ -168,7 +168,7 @@
         <p:txBody>
           <a:bodyPr/>
           <a:p>
-            <a:fld id="{6E37AE54-4AAC-4977-9008-47BBA8658802}" type="slidenum">
+            <a:fld id="{8E51342F-CCB4-4F9D-ABFE-4A52F5FB7767}" type="slidenum">
               <a:t>&lt;#&gt;</a:t>
             </a:fld>
           </a:p>
@@ -251,7 +251,7 @@
         <p:txBody>
           <a:bodyPr/>
           <a:p>
-            <a:fld id="{70EB8945-3A4A-4D21-B78F-9FAA10BE92E9}" type="slidenum">
+            <a:fld id="{4F5C79E1-9623-450A-AEA2-7EDEEE8B8ABF}" type="slidenum">
               <a:t>&lt;#&gt;</a:t>
             </a:fld>
           </a:p>
@@ -334,7 +334,7 @@
         <p:txBody>
           <a:bodyPr/>
           <a:p>
-            <a:fld id="{0D39A25F-893A-45B5-A515-4974A628AEF9}" type="slidenum">
+            <a:fld id="{CD588D02-E62A-483D-BC32-986B5B43E10C}" type="slidenum">
               <a:t>&lt;#&gt;</a:t>
             </a:fld>
           </a:p>
@@ -417,7 +417,7 @@
         <p:txBody>
           <a:bodyPr/>
           <a:p>
-            <a:fld id="{A0CE96FF-F520-40C9-80F7-CFF858C55F60}" type="slidenum">
+            <a:fld id="{C64111A4-9E7F-4E61-A9A2-0EFABD5F8825}" type="slidenum">
               <a:t>&lt;#&gt;</a:t>
             </a:fld>
           </a:p>
@@ -500,7 +500,7 @@
         <p:txBody>
           <a:bodyPr/>
           <a:p>
-            <a:fld id="{427CF901-B60C-4617-8DEA-592ABC88DB76}" type="slidenum">
+            <a:fld id="{7782EC05-E175-4625-8BE8-8C9DB4D939B1}" type="slidenum">
               <a:t>&lt;#&gt;</a:t>
             </a:fld>
           </a:p>
@@ -666,7 +666,7 @@
         <p:txBody>
           <a:bodyPr/>
           <a:p>
-            <a:fld id="{AA5EAB83-160D-4C02-B0A3-3E4985DD7EB3}" type="slidenum">
+            <a:fld id="{E48214CE-97F8-4562-B4FC-E27D47B04290}" type="slidenum">
               <a:t>&lt;#&gt;</a:t>
             </a:fld>
           </a:p>
@@ -749,7 +749,7 @@
         <p:txBody>
           <a:bodyPr/>
           <a:p>
-            <a:fld id="{EB9FFB88-518D-455D-9B7A-97B1D4F101D5}" type="slidenum">
+            <a:fld id="{078061BF-1001-42A3-838A-F4EBB4E1F96F}" type="slidenum">
               <a:t>&lt;#&gt;</a:t>
             </a:fld>
           </a:p>
@@ -958,7 +958,7 @@
         <p:txBody>
           <a:bodyPr/>
           <a:p>
-            <a:fld id="{EF33AEFE-7AA5-46A6-A3FB-5F8A68E6F480}" type="slidenum">
+            <a:fld id="{F33D069D-CCFE-46ED-849A-DD1DB6CB2120}" type="slidenum">
               <a:t>&lt;#&gt;</a:t>
             </a:fld>
           </a:p>
@@ -1041,7 +1041,7 @@
         <p:txBody>
           <a:bodyPr/>
           <a:p>
-            <a:fld id="{BF5FB82C-D531-4BF9-BF1F-77A451388F49}" type="slidenum">
+            <a:fld id="{A1DF039A-9164-4896-A7E5-B2BFC07DE3A3}" type="slidenum">
               <a:t>&lt;#&gt;</a:t>
             </a:fld>
           </a:p>
@@ -1164,7 +1164,7 @@
         <p:txBody>
           <a:bodyPr/>
           <a:p>
-            <a:fld id="{FE680ED9-790F-4890-966D-89E6454EB41F}" type="slidenum">
+            <a:fld id="{00A69D65-CD70-482A-B8B5-4D30EFF6229C}" type="slidenum">
               <a:t>&lt;#&gt;</a:t>
             </a:fld>
           </a:p>
@@ -1247,7 +1247,7 @@
         <p:txBody>
           <a:bodyPr/>
           <a:p>
-            <a:fld id="{4379A4B3-A36F-4602-BA52-84D5903F384B}" type="slidenum">
+            <a:fld id="{8A1CE3C5-C989-412A-A4A3-D95EF406EA31}" type="slidenum">
               <a:t>&lt;#&gt;</a:t>
             </a:fld>
           </a:p>
@@ -1341,7 +1341,25 @@
                 </a:solidFill>
                 <a:latin typeface="Arial"/>
               </a:rPr>
-              <a:t>Click to edit the title text format</a:t>
+              <a:t>Click to edit </a:t>
+            </a:r>
+            <a:r>
+              <a:rPr b="0" lang="pt-BR" sz="1800" spc="-1" strike="noStrike">
+                <a:solidFill>
+                  <a:srgbClr val="000000"/>
+                </a:solidFill>
+                <a:latin typeface="Arial"/>
+              </a:rPr>
+              <a:t>the title text </a:t>
+            </a:r>
+            <a:r>
+              <a:rPr b="0" lang="pt-BR" sz="1800" spc="-1" strike="noStrike">
+                <a:solidFill>
+                  <a:srgbClr val="000000"/>
+                </a:solidFill>
+                <a:latin typeface="Arial"/>
+              </a:rPr>
+              <a:t>format</a:t>
             </a:r>
             <a:endParaRPr b="0" lang="pt-BR" sz="1800" spc="-1" strike="noStrike">
               <a:solidFill>
@@ -1365,7 +1383,7 @@
         <p:spPr>
           <a:xfrm>
             <a:off x="3124080" y="6356520"/>
-            <a:ext cx="2894760" cy="364320"/>
+            <a:ext cx="2894400" cy="363960"/>
           </a:xfrm>
           <a:prstGeom prst="rect">
             <a:avLst/>
@@ -1437,7 +1455,7 @@
         <p:spPr>
           <a:xfrm>
             <a:off x="6553080" y="6356520"/>
-            <a:ext cx="2133000" cy="364320"/>
+            <a:ext cx="2132640" cy="363960"/>
           </a:xfrm>
           <a:prstGeom prst="rect">
             <a:avLst/>
@@ -1480,7 +1498,7 @@
                 <a:tab algn="l" pos="0"/>
               </a:tabLst>
             </a:pPr>
-            <a:fld id="{0A8ACBAD-7962-4193-90EE-3F0C6BE2B173}" type="slidenum">
+            <a:fld id="{F56F3999-6CAE-401B-B70D-FBD2C112F7C5}" type="slidenum">
               <a:rPr b="0" lang="en-US" sz="1200" spc="-1" strike="noStrike">
                 <a:solidFill>
                   <a:schemeClr val="dk1">
@@ -1513,7 +1531,7 @@
         <p:spPr>
           <a:xfrm>
             <a:off x="457200" y="6356520"/>
-            <a:ext cx="2133000" cy="364320"/>
+            <a:ext cx="2132640" cy="363960"/>
           </a:xfrm>
           <a:prstGeom prst="rect">
             <a:avLst/>
@@ -1606,7 +1624,7 @@
         <p:spPr>
           <a:xfrm>
             <a:off x="3124080" y="6356520"/>
-            <a:ext cx="2894760" cy="364320"/>
+            <a:ext cx="2894400" cy="363960"/>
           </a:xfrm>
           <a:prstGeom prst="rect">
             <a:avLst/>
@@ -1678,7 +1696,7 @@
         <p:spPr>
           <a:xfrm>
             <a:off x="6553080" y="6356520"/>
-            <a:ext cx="2133000" cy="364320"/>
+            <a:ext cx="2132640" cy="363960"/>
           </a:xfrm>
           <a:prstGeom prst="rect">
             <a:avLst/>
@@ -1721,7 +1739,7 @@
                 <a:tab algn="l" pos="0"/>
               </a:tabLst>
             </a:pPr>
-            <a:fld id="{1241308A-9C47-4068-9073-724556E03FC5}" type="slidenum">
+            <a:fld id="{A6C274B7-C947-4040-9404-ED8BAB99825A}" type="slidenum">
               <a:rPr b="0" lang="en-US" sz="1200" spc="-1" strike="noStrike">
                 <a:solidFill>
                   <a:schemeClr val="dk1">
@@ -1754,7 +1772,7 @@
         <p:spPr>
           <a:xfrm>
             <a:off x="457200" y="6356520"/>
-            <a:ext cx="2133000" cy="364320"/>
+            <a:ext cx="2132640" cy="363960"/>
           </a:xfrm>
           <a:prstGeom prst="rect">
             <a:avLst/>
@@ -1847,7 +1865,7 @@
         <p:spPr>
           <a:xfrm>
             <a:off x="3124080" y="6356520"/>
-            <a:ext cx="2894760" cy="364320"/>
+            <a:ext cx="2894400" cy="363960"/>
           </a:xfrm>
           <a:prstGeom prst="rect">
             <a:avLst/>
@@ -1919,7 +1937,7 @@
         <p:spPr>
           <a:xfrm>
             <a:off x="6553080" y="6356520"/>
-            <a:ext cx="2133000" cy="364320"/>
+            <a:ext cx="2132640" cy="363960"/>
           </a:xfrm>
           <a:prstGeom prst="rect">
             <a:avLst/>
@@ -1962,7 +1980,7 @@
                 <a:tab algn="l" pos="0"/>
               </a:tabLst>
             </a:pPr>
-            <a:fld id="{6066AF13-2894-4983-AEAE-11473FD480B0}" type="slidenum">
+            <a:fld id="{DFCE30AA-7E4E-48A9-8131-B2F9461E430C}" type="slidenum">
               <a:rPr b="0" lang="en-US" sz="1200" spc="-1" strike="noStrike">
                 <a:solidFill>
                   <a:schemeClr val="dk1">
@@ -1995,7 +2013,7 @@
         <p:spPr>
           <a:xfrm>
             <a:off x="457200" y="6356520"/>
-            <a:ext cx="2133000" cy="364320"/>
+            <a:ext cx="2132640" cy="363960"/>
           </a:xfrm>
           <a:prstGeom prst="rect">
             <a:avLst/>
@@ -2088,7 +2106,7 @@
         <p:spPr>
           <a:xfrm>
             <a:off x="3124080" y="6356520"/>
-            <a:ext cx="2894760" cy="364320"/>
+            <a:ext cx="2894400" cy="363960"/>
           </a:xfrm>
           <a:prstGeom prst="rect">
             <a:avLst/>
@@ -2160,7 +2178,7 @@
         <p:spPr>
           <a:xfrm>
             <a:off x="6553080" y="6356520"/>
-            <a:ext cx="2133000" cy="364320"/>
+            <a:ext cx="2132640" cy="363960"/>
           </a:xfrm>
           <a:prstGeom prst="rect">
             <a:avLst/>
@@ -2203,7 +2221,7 @@
                 <a:tab algn="l" pos="0"/>
               </a:tabLst>
             </a:pPr>
-            <a:fld id="{A97FFC04-B920-438A-8776-B28979D57CCB}" type="slidenum">
+            <a:fld id="{C37F7363-9304-4204-8592-2A92D2D19222}" type="slidenum">
               <a:rPr b="0" lang="en-US" sz="1200" spc="-1" strike="noStrike">
                 <a:solidFill>
                   <a:schemeClr val="dk1">
@@ -2236,7 +2254,7 @@
         <p:spPr>
           <a:xfrm>
             <a:off x="457200" y="6356520"/>
-            <a:ext cx="2133000" cy="364320"/>
+            <a:ext cx="2132640" cy="363960"/>
           </a:xfrm>
           <a:prstGeom prst="rect">
             <a:avLst/>
@@ -2329,7 +2347,7 @@
         <p:spPr>
           <a:xfrm>
             <a:off x="3124080" y="6356520"/>
-            <a:ext cx="2894760" cy="364320"/>
+            <a:ext cx="2894400" cy="363960"/>
           </a:xfrm>
           <a:prstGeom prst="rect">
             <a:avLst/>
@@ -2401,7 +2419,7 @@
         <p:spPr>
           <a:xfrm>
             <a:off x="6553080" y="6356520"/>
-            <a:ext cx="2133000" cy="364320"/>
+            <a:ext cx="2132640" cy="363960"/>
           </a:xfrm>
           <a:prstGeom prst="rect">
             <a:avLst/>
@@ -2444,7 +2462,7 @@
                 <a:tab algn="l" pos="0"/>
               </a:tabLst>
             </a:pPr>
-            <a:fld id="{F98C0405-8740-464F-97F4-6362697D086C}" type="slidenum">
+            <a:fld id="{32FCCC7B-6F4C-435F-BD55-CC1A43ED8C08}" type="slidenum">
               <a:rPr b="0" lang="en-US" sz="1200" spc="-1" strike="noStrike">
                 <a:solidFill>
                   <a:schemeClr val="dk1">
@@ -2477,7 +2495,7 @@
         <p:spPr>
           <a:xfrm>
             <a:off x="457200" y="6356520"/>
-            <a:ext cx="2133000" cy="364320"/>
+            <a:ext cx="2132640" cy="363960"/>
           </a:xfrm>
           <a:prstGeom prst="rect">
             <a:avLst/>
@@ -2844,7 +2862,7 @@
         <p:spPr>
           <a:xfrm>
             <a:off x="3124080" y="6356520"/>
-            <a:ext cx="2894760" cy="364320"/>
+            <a:ext cx="2894400" cy="363960"/>
           </a:xfrm>
           <a:prstGeom prst="rect">
             <a:avLst/>
@@ -2916,7 +2934,7 @@
         <p:spPr>
           <a:xfrm>
             <a:off x="6553080" y="6356520"/>
-            <a:ext cx="2133000" cy="364320"/>
+            <a:ext cx="2132640" cy="363960"/>
           </a:xfrm>
           <a:prstGeom prst="rect">
             <a:avLst/>
@@ -2959,7 +2977,7 @@
                 <a:tab algn="l" pos="0"/>
               </a:tabLst>
             </a:pPr>
-            <a:fld id="{5BE45850-BD7F-4885-AC55-1C4B773A0337}" type="slidenum">
+            <a:fld id="{610C7EE5-BDCC-4BAA-8B5E-071C0EBCF15B}" type="slidenum">
               <a:rPr b="0" lang="en-US" sz="1200" spc="-1" strike="noStrike">
                 <a:solidFill>
                   <a:schemeClr val="dk1">
@@ -2992,7 +3010,7 @@
         <p:spPr>
           <a:xfrm>
             <a:off x="457200" y="6356520"/>
-            <a:ext cx="2133000" cy="364320"/>
+            <a:ext cx="2132640" cy="363960"/>
           </a:xfrm>
           <a:prstGeom prst="rect">
             <a:avLst/>
@@ -3085,7 +3103,7 @@
         <p:spPr>
           <a:xfrm>
             <a:off x="3124080" y="6356520"/>
-            <a:ext cx="2894760" cy="364320"/>
+            <a:ext cx="2894400" cy="363960"/>
           </a:xfrm>
           <a:prstGeom prst="rect">
             <a:avLst/>
@@ -3157,7 +3175,7 @@
         <p:spPr>
           <a:xfrm>
             <a:off x="6553080" y="6356520"/>
-            <a:ext cx="2133000" cy="364320"/>
+            <a:ext cx="2132640" cy="363960"/>
           </a:xfrm>
           <a:prstGeom prst="rect">
             <a:avLst/>
@@ -3200,7 +3218,7 @@
                 <a:tab algn="l" pos="0"/>
               </a:tabLst>
             </a:pPr>
-            <a:fld id="{856152C4-02F0-429D-8984-6C31E4CBF86F}" type="slidenum">
+            <a:fld id="{D6DA5413-1F88-4BC4-BDCC-73257571D75C}" type="slidenum">
               <a:rPr b="0" lang="en-US" sz="1200" spc="-1" strike="noStrike">
                 <a:solidFill>
                   <a:schemeClr val="dk1">
@@ -3233,7 +3251,7 @@
         <p:spPr>
           <a:xfrm>
             <a:off x="457200" y="6356520"/>
-            <a:ext cx="2133000" cy="364320"/>
+            <a:ext cx="2132640" cy="363960"/>
           </a:xfrm>
           <a:prstGeom prst="rect">
             <a:avLst/>
@@ -3825,7 +3843,7 @@
         <p:spPr>
           <a:xfrm>
             <a:off x="3124080" y="6356520"/>
-            <a:ext cx="2894760" cy="364320"/>
+            <a:ext cx="2894400" cy="363960"/>
           </a:xfrm>
           <a:prstGeom prst="rect">
             <a:avLst/>
@@ -3897,7 +3915,7 @@
         <p:spPr>
           <a:xfrm>
             <a:off x="6553080" y="6356520"/>
-            <a:ext cx="2133000" cy="364320"/>
+            <a:ext cx="2132640" cy="363960"/>
           </a:xfrm>
           <a:prstGeom prst="rect">
             <a:avLst/>
@@ -3940,7 +3958,7 @@
                 <a:tab algn="l" pos="0"/>
               </a:tabLst>
             </a:pPr>
-            <a:fld id="{F8F1260D-D3E2-49AB-BB2F-DBFDC8978A7C}" type="slidenum">
+            <a:fld id="{2EE0595C-3153-4334-AF31-8B80D1AA1BB0}" type="slidenum">
               <a:rPr b="0" lang="en-US" sz="1200" spc="-1" strike="noStrike">
                 <a:solidFill>
                   <a:schemeClr val="dk1">
@@ -3973,7 +3991,7 @@
         <p:spPr>
           <a:xfrm>
             <a:off x="457200" y="6356520"/>
-            <a:ext cx="2133000" cy="364320"/>
+            <a:ext cx="2132640" cy="363960"/>
           </a:xfrm>
           <a:prstGeom prst="rect">
             <a:avLst/>
@@ -4066,7 +4084,7 @@
         <p:spPr>
           <a:xfrm>
             <a:off x="3124080" y="6356520"/>
-            <a:ext cx="2894760" cy="364320"/>
+            <a:ext cx="2894400" cy="363960"/>
           </a:xfrm>
           <a:prstGeom prst="rect">
             <a:avLst/>
@@ -4138,7 +4156,7 @@
         <p:spPr>
           <a:xfrm>
             <a:off x="6553080" y="6356520"/>
-            <a:ext cx="2133000" cy="364320"/>
+            <a:ext cx="2132640" cy="363960"/>
           </a:xfrm>
           <a:prstGeom prst="rect">
             <a:avLst/>
@@ -4181,7 +4199,7 @@
                 <a:tab algn="l" pos="0"/>
               </a:tabLst>
             </a:pPr>
-            <a:fld id="{212A63AF-957F-4A74-B6CE-DD4BF18F34F0}" type="slidenum">
+            <a:fld id="{93A6E31B-45CF-41D1-812F-B5D5F5737D25}" type="slidenum">
               <a:rPr b="0" lang="en-US" sz="1200" spc="-1" strike="noStrike">
                 <a:solidFill>
                   <a:schemeClr val="dk1">
@@ -4214,7 +4232,7 @@
         <p:spPr>
           <a:xfrm>
             <a:off x="457200" y="6356520"/>
-            <a:ext cx="2133000" cy="364320"/>
+            <a:ext cx="2132640" cy="363960"/>
           </a:xfrm>
           <a:prstGeom prst="rect">
             <a:avLst/>
@@ -4356,7 +4374,7 @@
         <p:spPr>
           <a:xfrm>
             <a:off x="3124080" y="6356520"/>
-            <a:ext cx="2894760" cy="364320"/>
+            <a:ext cx="2894400" cy="363960"/>
           </a:xfrm>
           <a:prstGeom prst="rect">
             <a:avLst/>
@@ -4428,7 +4446,7 @@
         <p:spPr>
           <a:xfrm>
             <a:off x="6553080" y="6356520"/>
-            <a:ext cx="2133000" cy="364320"/>
+            <a:ext cx="2132640" cy="363960"/>
           </a:xfrm>
           <a:prstGeom prst="rect">
             <a:avLst/>
@@ -4471,7 +4489,7 @@
                 <a:tab algn="l" pos="0"/>
               </a:tabLst>
             </a:pPr>
-            <a:fld id="{A2978034-8731-446C-99D9-26E4A990B765}" type="slidenum">
+            <a:fld id="{021D2B98-3646-40A5-BD81-0C0F93BB3F77}" type="slidenum">
               <a:rPr b="0" lang="en-US" sz="1200" spc="-1" strike="noStrike">
                 <a:solidFill>
                   <a:schemeClr val="dk1">
@@ -4504,7 +4522,7 @@
         <p:spPr>
           <a:xfrm>
             <a:off x="457200" y="6356520"/>
-            <a:ext cx="2133000" cy="364320"/>
+            <a:ext cx="2132640" cy="363960"/>
           </a:xfrm>
           <a:prstGeom prst="rect">
             <a:avLst/>
@@ -4597,7 +4615,7 @@
         <p:spPr>
           <a:xfrm>
             <a:off x="3124080" y="6356520"/>
-            <a:ext cx="2894760" cy="364320"/>
+            <a:ext cx="2894400" cy="363960"/>
           </a:xfrm>
           <a:prstGeom prst="rect">
             <a:avLst/>
@@ -4669,7 +4687,7 @@
         <p:spPr>
           <a:xfrm>
             <a:off x="6553080" y="6356520"/>
-            <a:ext cx="2133000" cy="364320"/>
+            <a:ext cx="2132640" cy="363960"/>
           </a:xfrm>
           <a:prstGeom prst="rect">
             <a:avLst/>
@@ -4712,7 +4730,7 @@
                 <a:tab algn="l" pos="0"/>
               </a:tabLst>
             </a:pPr>
-            <a:fld id="{A97D3B2F-2AB0-4326-8ED4-62A50E8A2D82}" type="slidenum">
+            <a:fld id="{591C104C-6B5C-4250-A470-142BAFFD1247}" type="slidenum">
               <a:rPr b="0" lang="en-US" sz="1200" spc="-1" strike="noStrike">
                 <a:solidFill>
                   <a:schemeClr val="dk1">
@@ -4745,7 +4763,7 @@
         <p:spPr>
           <a:xfrm>
             <a:off x="457200" y="6356520"/>
-            <a:ext cx="2133000" cy="364320"/>
+            <a:ext cx="2132640" cy="363960"/>
           </a:xfrm>
           <a:prstGeom prst="rect">
             <a:avLst/>
@@ -5108,7 +5126,7 @@
         <p:spPr>
           <a:xfrm>
             <a:off x="0" y="0"/>
-            <a:ext cx="12188160" cy="227880"/>
+            <a:ext cx="12187800" cy="227520"/>
           </a:xfrm>
           <a:prstGeom prst="rect">
             <a:avLst/>
@@ -5170,7 +5188,7 @@
         <p:spPr>
           <a:xfrm>
             <a:off x="0" y="6656760"/>
-            <a:ext cx="12188160" cy="200520"/>
+            <a:ext cx="12187800" cy="200160"/>
           </a:xfrm>
           <a:prstGeom prst="rect">
             <a:avLst/>
@@ -5232,7 +5250,7 @@
         <p:spPr>
           <a:xfrm>
             <a:off x="0" y="228600"/>
-            <a:ext cx="136440" cy="6400080"/>
+            <a:ext cx="136080" cy="6399720"/>
           </a:xfrm>
           <a:prstGeom prst="rect">
             <a:avLst/>
@@ -5298,7 +5316,7 @@
         <p:spPr>
           <a:xfrm>
             <a:off x="8940600" y="255960"/>
-            <a:ext cx="3179160" cy="2115720"/>
+            <a:ext cx="3178800" cy="2115360"/>
           </a:xfrm>
           <a:prstGeom prst="rect">
             <a:avLst/>
@@ -5317,7 +5335,7 @@
         <p:spPr>
           <a:xfrm>
             <a:off x="707040" y="2450880"/>
-            <a:ext cx="8232840" cy="1587240"/>
+            <a:ext cx="8232480" cy="1587240"/>
           </a:xfrm>
           <a:prstGeom prst="rect">
             <a:avLst/>
@@ -5389,7 +5407,7 @@
         <p:spPr>
           <a:xfrm>
             <a:off x="644400" y="3763440"/>
-            <a:ext cx="5339160" cy="700200"/>
+            <a:ext cx="5338800" cy="699480"/>
           </a:xfrm>
           <a:prstGeom prst="rect">
             <a:avLst/>
@@ -5464,7 +5482,7 @@
         <p:spPr>
           <a:xfrm>
             <a:off x="644400" y="5301720"/>
-            <a:ext cx="5179320" cy="638280"/>
+            <a:ext cx="5178960" cy="638280"/>
           </a:xfrm>
           <a:prstGeom prst="rect">
             <a:avLst/>
@@ -5517,7 +5535,7 @@
         <p:spPr>
           <a:xfrm>
             <a:off x="677880" y="5951520"/>
-            <a:ext cx="6928920" cy="363960"/>
+            <a:ext cx="6928560" cy="363960"/>
           </a:xfrm>
           <a:prstGeom prst="rect">
             <a:avLst/>
@@ -5574,7 +5592,7 @@
         <p:spPr>
           <a:xfrm>
             <a:off x="68760" y="127440"/>
-            <a:ext cx="3709800" cy="1518120"/>
+            <a:ext cx="3709440" cy="1517760"/>
           </a:xfrm>
           <a:prstGeom prst="rect">
             <a:avLst/>
@@ -5597,7 +5615,7 @@
         <p:spPr>
           <a:xfrm>
             <a:off x="5984640" y="487800"/>
-            <a:ext cx="2276640" cy="1199160"/>
+            <a:ext cx="2276280" cy="1198800"/>
           </a:xfrm>
           <a:prstGeom prst="rect">
             <a:avLst/>
@@ -5626,7 +5644,7 @@
         <p:spPr>
           <a:xfrm>
             <a:off x="3847680" y="378360"/>
-            <a:ext cx="1512360" cy="996840"/>
+            <a:ext cx="1512000" cy="996480"/>
           </a:xfrm>
           <a:prstGeom prst="rect">
             <a:avLst/>
@@ -5682,7 +5700,7 @@
         <p:spPr>
           <a:xfrm>
             <a:off x="0" y="0"/>
-            <a:ext cx="12188160" cy="227880"/>
+            <a:ext cx="12187800" cy="227520"/>
           </a:xfrm>
           <a:prstGeom prst="rect">
             <a:avLst/>
@@ -5744,7 +5762,7 @@
         <p:spPr>
           <a:xfrm>
             <a:off x="0" y="6656760"/>
-            <a:ext cx="12188160" cy="200520"/>
+            <a:ext cx="12187800" cy="200160"/>
           </a:xfrm>
           <a:prstGeom prst="rect">
             <a:avLst/>
@@ -5806,7 +5824,7 @@
         <p:spPr>
           <a:xfrm>
             <a:off x="0" y="228600"/>
-            <a:ext cx="136440" cy="6400080"/>
+            <a:ext cx="136080" cy="6399720"/>
           </a:xfrm>
           <a:prstGeom prst="rect">
             <a:avLst/>
@@ -5927,7 +5945,7 @@
         <p:spPr>
           <a:xfrm>
             <a:off x="548640" y="1280160"/>
-            <a:ext cx="9344160" cy="4957920"/>
+            <a:ext cx="9343800" cy="4957560"/>
           </a:xfrm>
           <a:prstGeom prst="roundRect">
             <a:avLst>
@@ -5995,7 +6013,7 @@
         <p:spPr>
           <a:xfrm>
             <a:off x="10013760" y="330480"/>
-            <a:ext cx="2136600" cy="1421640"/>
+            <a:ext cx="2136240" cy="1421280"/>
           </a:xfrm>
           <a:prstGeom prst="rect">
             <a:avLst/>
@@ -6018,7 +6036,7 @@
         <p:spPr>
           <a:xfrm>
             <a:off x="10118880" y="2329560"/>
-            <a:ext cx="2031120" cy="1069920"/>
+            <a:ext cx="2030760" cy="1069560"/>
           </a:xfrm>
           <a:prstGeom prst="rect">
             <a:avLst/>
@@ -6047,7 +6065,7 @@
         <p:spPr>
           <a:xfrm>
             <a:off x="10577160" y="3787560"/>
-            <a:ext cx="1393920" cy="1043280"/>
+            <a:ext cx="1393560" cy="1042920"/>
           </a:xfrm>
           <a:prstGeom prst="rect">
             <a:avLst/>
@@ -6070,7 +6088,7 @@
         <p:spPr>
           <a:xfrm>
             <a:off x="9668520" y="5452200"/>
-            <a:ext cx="2626560" cy="1074600"/>
+            <a:ext cx="2626200" cy="1074240"/>
           </a:xfrm>
           <a:prstGeom prst="rect">
             <a:avLst/>
@@ -6093,7 +6111,7 @@
         <p:spPr>
           <a:xfrm>
             <a:off x="734760" y="1620000"/>
-            <a:ext cx="8984880" cy="4139640"/>
+            <a:ext cx="8984520" cy="4139280"/>
           </a:xfrm>
           <a:prstGeom prst="rect">
             <a:avLst/>
@@ -6149,7 +6167,7 @@
         <p:spPr>
           <a:xfrm>
             <a:off x="0" y="0"/>
-            <a:ext cx="12188160" cy="227880"/>
+            <a:ext cx="12187800" cy="227520"/>
           </a:xfrm>
           <a:prstGeom prst="rect">
             <a:avLst/>
@@ -6211,7 +6229,7 @@
         <p:spPr>
           <a:xfrm>
             <a:off x="0" y="6656760"/>
-            <a:ext cx="12188160" cy="200520"/>
+            <a:ext cx="12187800" cy="200160"/>
           </a:xfrm>
           <a:prstGeom prst="rect">
             <a:avLst/>
@@ -6273,7 +6291,7 @@
         <p:spPr>
           <a:xfrm>
             <a:off x="0" y="228600"/>
-            <a:ext cx="136440" cy="6400080"/>
+            <a:ext cx="136080" cy="6399720"/>
           </a:xfrm>
           <a:prstGeom prst="rect">
             <a:avLst/>
@@ -6394,7 +6412,7 @@
         <p:spPr>
           <a:xfrm>
             <a:off x="548640" y="1280160"/>
-            <a:ext cx="9344160" cy="4957920"/>
+            <a:ext cx="9343800" cy="4957560"/>
           </a:xfrm>
           <a:prstGeom prst="roundRect">
             <a:avLst>
@@ -6462,7 +6480,7 @@
         <p:spPr>
           <a:xfrm>
             <a:off x="10013760" y="330480"/>
-            <a:ext cx="2136600" cy="1421640"/>
+            <a:ext cx="2136240" cy="1421280"/>
           </a:xfrm>
           <a:prstGeom prst="rect">
             <a:avLst/>
@@ -6485,7 +6503,7 @@
         <p:spPr>
           <a:xfrm>
             <a:off x="10118880" y="2329560"/>
-            <a:ext cx="2031120" cy="1069920"/>
+            <a:ext cx="2030760" cy="1069560"/>
           </a:xfrm>
           <a:prstGeom prst="rect">
             <a:avLst/>
@@ -6514,7 +6532,7 @@
         <p:spPr>
           <a:xfrm>
             <a:off x="10577160" y="3787560"/>
-            <a:ext cx="1393920" cy="1043280"/>
+            <a:ext cx="1393560" cy="1042920"/>
           </a:xfrm>
           <a:prstGeom prst="rect">
             <a:avLst/>
@@ -6537,7 +6555,7 @@
         <p:spPr>
           <a:xfrm>
             <a:off x="9668520" y="5452200"/>
-            <a:ext cx="2626560" cy="1074600"/>
+            <a:ext cx="2626200" cy="1074240"/>
           </a:xfrm>
           <a:prstGeom prst="rect">
             <a:avLst/>
@@ -6560,7 +6578,7 @@
         <p:spPr>
           <a:xfrm>
             <a:off x="900000" y="1620000"/>
-            <a:ext cx="8639640" cy="4310640"/>
+            <a:ext cx="8639280" cy="4310280"/>
           </a:xfrm>
           <a:prstGeom prst="rect">
             <a:avLst/>
@@ -6616,7 +6634,7 @@
         <p:spPr>
           <a:xfrm>
             <a:off x="0" y="0"/>
-            <a:ext cx="12188160" cy="227880"/>
+            <a:ext cx="12187800" cy="227520"/>
           </a:xfrm>
           <a:prstGeom prst="rect">
             <a:avLst/>
@@ -6678,7 +6696,7 @@
         <p:spPr>
           <a:xfrm>
             <a:off x="0" y="6656760"/>
-            <a:ext cx="12188160" cy="200520"/>
+            <a:ext cx="12187800" cy="200160"/>
           </a:xfrm>
           <a:prstGeom prst="rect">
             <a:avLst/>
@@ -6740,7 +6758,7 @@
         <p:spPr>
           <a:xfrm>
             <a:off x="0" y="228600"/>
-            <a:ext cx="136440" cy="6400080"/>
+            <a:ext cx="136080" cy="6399720"/>
           </a:xfrm>
           <a:prstGeom prst="rect">
             <a:avLst/>
@@ -6861,7 +6879,7 @@
         <p:spPr>
           <a:xfrm>
             <a:off x="548640" y="1280160"/>
-            <a:ext cx="9344160" cy="4957920"/>
+            <a:ext cx="9343800" cy="4957560"/>
           </a:xfrm>
           <a:prstGeom prst="roundRect">
             <a:avLst>
@@ -6929,7 +6947,7 @@
         <p:spPr>
           <a:xfrm>
             <a:off x="10013760" y="330480"/>
-            <a:ext cx="2136600" cy="1421640"/>
+            <a:ext cx="2136240" cy="1421280"/>
           </a:xfrm>
           <a:prstGeom prst="rect">
             <a:avLst/>
@@ -6952,7 +6970,7 @@
         <p:spPr>
           <a:xfrm>
             <a:off x="10118880" y="2329560"/>
-            <a:ext cx="2031120" cy="1069920"/>
+            <a:ext cx="2030760" cy="1069560"/>
           </a:xfrm>
           <a:prstGeom prst="rect">
             <a:avLst/>
@@ -6981,7 +6999,7 @@
         <p:spPr>
           <a:xfrm>
             <a:off x="10577160" y="3787560"/>
-            <a:ext cx="1393920" cy="1043280"/>
+            <a:ext cx="1393560" cy="1042920"/>
           </a:xfrm>
           <a:prstGeom prst="rect">
             <a:avLst/>
@@ -7004,7 +7022,7 @@
         <p:spPr>
           <a:xfrm>
             <a:off x="9668520" y="5452200"/>
-            <a:ext cx="2626560" cy="1074600"/>
+            <a:ext cx="2626200" cy="1074240"/>
           </a:xfrm>
           <a:prstGeom prst="rect">
             <a:avLst/>
@@ -7027,7 +7045,7 @@
         <p:spPr>
           <a:xfrm>
             <a:off x="856080" y="1620000"/>
-            <a:ext cx="8755560" cy="4232520"/>
+            <a:ext cx="8755200" cy="4232160"/>
           </a:xfrm>
           <a:prstGeom prst="rect">
             <a:avLst/>
@@ -7083,7 +7101,7 @@
         <p:spPr>
           <a:xfrm>
             <a:off x="0" y="0"/>
-            <a:ext cx="12188160" cy="227880"/>
+            <a:ext cx="12187800" cy="227520"/>
           </a:xfrm>
           <a:prstGeom prst="rect">
             <a:avLst/>
@@ -7145,7 +7163,7 @@
         <p:spPr>
           <a:xfrm>
             <a:off x="0" y="6656760"/>
-            <a:ext cx="12188160" cy="200520"/>
+            <a:ext cx="12187800" cy="200160"/>
           </a:xfrm>
           <a:prstGeom prst="rect">
             <a:avLst/>
@@ -7207,7 +7225,7 @@
         <p:spPr>
           <a:xfrm>
             <a:off x="0" y="228600"/>
-            <a:ext cx="136440" cy="6400080"/>
+            <a:ext cx="136080" cy="6399720"/>
           </a:xfrm>
           <a:prstGeom prst="rect">
             <a:avLst/>
@@ -7328,7 +7346,7 @@
         <p:spPr>
           <a:xfrm>
             <a:off x="548640" y="1280160"/>
-            <a:ext cx="9344160" cy="4957920"/>
+            <a:ext cx="9343800" cy="4957560"/>
           </a:xfrm>
           <a:prstGeom prst="roundRect">
             <a:avLst>
@@ -7396,7 +7414,7 @@
         <p:spPr>
           <a:xfrm>
             <a:off x="10013760" y="330480"/>
-            <a:ext cx="2136600" cy="1421640"/>
+            <a:ext cx="2136240" cy="1421280"/>
           </a:xfrm>
           <a:prstGeom prst="rect">
             <a:avLst/>
@@ -7419,7 +7437,7 @@
         <p:spPr>
           <a:xfrm>
             <a:off x="10118880" y="2329560"/>
-            <a:ext cx="2031120" cy="1069920"/>
+            <a:ext cx="2030760" cy="1069560"/>
           </a:xfrm>
           <a:prstGeom prst="rect">
             <a:avLst/>
@@ -7448,7 +7466,7 @@
         <p:spPr>
           <a:xfrm>
             <a:off x="10577160" y="3787560"/>
-            <a:ext cx="1393920" cy="1043280"/>
+            <a:ext cx="1393560" cy="1042920"/>
           </a:xfrm>
           <a:prstGeom prst="rect">
             <a:avLst/>
@@ -7471,7 +7489,7 @@
         <p:spPr>
           <a:xfrm>
             <a:off x="9668520" y="5452200"/>
-            <a:ext cx="2626560" cy="1074600"/>
+            <a:ext cx="2626200" cy="1074240"/>
           </a:xfrm>
           <a:prstGeom prst="rect">
             <a:avLst/>
@@ -7494,7 +7512,7 @@
         <p:spPr>
           <a:xfrm>
             <a:off x="828720" y="1656000"/>
-            <a:ext cx="8746920" cy="4192560"/>
+            <a:ext cx="8746560" cy="4192200"/>
           </a:xfrm>
           <a:prstGeom prst="rect">
             <a:avLst/>
@@ -7550,7 +7568,7 @@
         <p:spPr>
           <a:xfrm>
             <a:off x="0" y="0"/>
-            <a:ext cx="12188160" cy="227880"/>
+            <a:ext cx="12187800" cy="227520"/>
           </a:xfrm>
           <a:prstGeom prst="rect">
             <a:avLst/>
@@ -7612,7 +7630,7 @@
         <p:spPr>
           <a:xfrm>
             <a:off x="0" y="6656760"/>
-            <a:ext cx="12188160" cy="200520"/>
+            <a:ext cx="12187800" cy="200160"/>
           </a:xfrm>
           <a:prstGeom prst="rect">
             <a:avLst/>
@@ -7674,7 +7692,7 @@
         <p:spPr>
           <a:xfrm>
             <a:off x="0" y="228600"/>
-            <a:ext cx="136440" cy="6400080"/>
+            <a:ext cx="136080" cy="6399720"/>
           </a:xfrm>
           <a:prstGeom prst="rect">
             <a:avLst/>
@@ -7795,7 +7813,7 @@
         <p:spPr>
           <a:xfrm>
             <a:off x="548640" y="1280160"/>
-            <a:ext cx="9344160" cy="4957920"/>
+            <a:ext cx="9343800" cy="4957560"/>
           </a:xfrm>
           <a:prstGeom prst="roundRect">
             <a:avLst>
@@ -7863,7 +7881,7 @@
         <p:spPr>
           <a:xfrm>
             <a:off x="10013760" y="330480"/>
-            <a:ext cx="2136600" cy="1421640"/>
+            <a:ext cx="2136240" cy="1421280"/>
           </a:xfrm>
           <a:prstGeom prst="rect">
             <a:avLst/>
@@ -7886,7 +7904,7 @@
         <p:spPr>
           <a:xfrm>
             <a:off x="10118880" y="2329560"/>
-            <a:ext cx="2031120" cy="1069920"/>
+            <a:ext cx="2030760" cy="1069560"/>
           </a:xfrm>
           <a:prstGeom prst="rect">
             <a:avLst/>
@@ -7915,7 +7933,7 @@
         <p:spPr>
           <a:xfrm>
             <a:off x="10577160" y="3787560"/>
-            <a:ext cx="1393920" cy="1043280"/>
+            <a:ext cx="1393560" cy="1042920"/>
           </a:xfrm>
           <a:prstGeom prst="rect">
             <a:avLst/>
@@ -7938,7 +7956,7 @@
         <p:spPr>
           <a:xfrm>
             <a:off x="9668520" y="5452200"/>
-            <a:ext cx="2626560" cy="1074600"/>
+            <a:ext cx="2626200" cy="1074240"/>
           </a:xfrm>
           <a:prstGeom prst="rect">
             <a:avLst/>
@@ -7961,7 +7979,7 @@
         <p:spPr>
           <a:xfrm>
             <a:off x="684000" y="2376000"/>
-            <a:ext cx="9086400" cy="2699640"/>
+            <a:ext cx="9086040" cy="2699280"/>
           </a:xfrm>
           <a:prstGeom prst="rect">
             <a:avLst/>
@@ -8017,7 +8035,7 @@
         <p:spPr>
           <a:xfrm>
             <a:off x="0" y="0"/>
-            <a:ext cx="12188160" cy="227880"/>
+            <a:ext cx="12187800" cy="227520"/>
           </a:xfrm>
           <a:prstGeom prst="rect">
             <a:avLst/>
@@ -8079,7 +8097,7 @@
         <p:spPr>
           <a:xfrm>
             <a:off x="0" y="6656760"/>
-            <a:ext cx="12188160" cy="200520"/>
+            <a:ext cx="12187800" cy="200160"/>
           </a:xfrm>
           <a:prstGeom prst="rect">
             <a:avLst/>
@@ -8141,7 +8159,7 @@
         <p:spPr>
           <a:xfrm>
             <a:off x="0" y="228600"/>
-            <a:ext cx="136440" cy="6400080"/>
+            <a:ext cx="136080" cy="6399720"/>
           </a:xfrm>
           <a:prstGeom prst="rect">
             <a:avLst/>
@@ -8262,7 +8280,7 @@
         <p:spPr>
           <a:xfrm>
             <a:off x="548640" y="1280160"/>
-            <a:ext cx="9344160" cy="4957920"/>
+            <a:ext cx="9343800" cy="4957560"/>
           </a:xfrm>
           <a:prstGeom prst="roundRect">
             <a:avLst>
@@ -8330,7 +8348,7 @@
         <p:spPr>
           <a:xfrm>
             <a:off x="10013760" y="330480"/>
-            <a:ext cx="2136600" cy="1421640"/>
+            <a:ext cx="2136240" cy="1421280"/>
           </a:xfrm>
           <a:prstGeom prst="rect">
             <a:avLst/>
@@ -8353,7 +8371,7 @@
         <p:spPr>
           <a:xfrm>
             <a:off x="10118880" y="2329560"/>
-            <a:ext cx="2031120" cy="1069920"/>
+            <a:ext cx="2030760" cy="1069560"/>
           </a:xfrm>
           <a:prstGeom prst="rect">
             <a:avLst/>
@@ -8382,7 +8400,7 @@
         <p:spPr>
           <a:xfrm>
             <a:off x="10577160" y="3787560"/>
-            <a:ext cx="1393920" cy="1043280"/>
+            <a:ext cx="1393560" cy="1042920"/>
           </a:xfrm>
           <a:prstGeom prst="rect">
             <a:avLst/>
@@ -8405,7 +8423,7 @@
         <p:spPr>
           <a:xfrm>
             <a:off x="9668520" y="5452200"/>
-            <a:ext cx="2626560" cy="1074600"/>
+            <a:ext cx="2626200" cy="1074240"/>
           </a:xfrm>
           <a:prstGeom prst="rect">
             <a:avLst/>
@@ -8428,7 +8446,7 @@
         <p:spPr>
           <a:xfrm>
             <a:off x="1089360" y="3164040"/>
-            <a:ext cx="8235360" cy="1079640"/>
+            <a:ext cx="8235000" cy="1079280"/>
           </a:xfrm>
           <a:prstGeom prst="rect">
             <a:avLst/>
@@ -8484,7 +8502,7 @@
         <p:spPr>
           <a:xfrm>
             <a:off x="0" y="0"/>
-            <a:ext cx="12188160" cy="227880"/>
+            <a:ext cx="12187800" cy="227520"/>
           </a:xfrm>
           <a:prstGeom prst="rect">
             <a:avLst/>
@@ -8546,7 +8564,7 @@
         <p:spPr>
           <a:xfrm>
             <a:off x="0" y="6656760"/>
-            <a:ext cx="12188160" cy="200520"/>
+            <a:ext cx="12187800" cy="200160"/>
           </a:xfrm>
           <a:prstGeom prst="rect">
             <a:avLst/>
@@ -8608,7 +8626,7 @@
         <p:spPr>
           <a:xfrm>
             <a:off x="0" y="228600"/>
-            <a:ext cx="136440" cy="6400080"/>
+            <a:ext cx="136080" cy="6399720"/>
           </a:xfrm>
           <a:prstGeom prst="rect">
             <a:avLst/>
@@ -8674,7 +8692,7 @@
         <p:spPr>
           <a:xfrm>
             <a:off x="8940600" y="255960"/>
-            <a:ext cx="3179160" cy="2115720"/>
+            <a:ext cx="3178800" cy="2115360"/>
           </a:xfrm>
           <a:prstGeom prst="rect">
             <a:avLst/>
@@ -8693,7 +8711,7 @@
         <p:spPr>
           <a:xfrm>
             <a:off x="1483920" y="2834640"/>
-            <a:ext cx="8848080" cy="607680"/>
+            <a:ext cx="8847720" cy="607680"/>
           </a:xfrm>
           <a:prstGeom prst="rect">
             <a:avLst/>
@@ -8746,7 +8764,7 @@
         <p:spPr>
           <a:xfrm>
             <a:off x="1618920" y="3657600"/>
-            <a:ext cx="8438760" cy="424800"/>
+            <a:ext cx="8438400" cy="424800"/>
           </a:xfrm>
           <a:prstGeom prst="rect">
             <a:avLst/>
@@ -8803,7 +8821,7 @@
         <p:spPr>
           <a:xfrm>
             <a:off x="5984640" y="487800"/>
-            <a:ext cx="2276640" cy="1199160"/>
+            <a:ext cx="2276280" cy="1198800"/>
           </a:xfrm>
           <a:prstGeom prst="rect">
             <a:avLst/>
@@ -8832,7 +8850,7 @@
         <p:spPr>
           <a:xfrm>
             <a:off x="3847680" y="378360"/>
-            <a:ext cx="1512360" cy="996840"/>
+            <a:ext cx="1512000" cy="996480"/>
           </a:xfrm>
           <a:prstGeom prst="rect">
             <a:avLst/>
@@ -8855,7 +8873,7 @@
         <p:spPr>
           <a:xfrm>
             <a:off x="68760" y="127440"/>
-            <a:ext cx="3709800" cy="1518120"/>
+            <a:ext cx="3709440" cy="1517760"/>
           </a:xfrm>
           <a:prstGeom prst="rect">
             <a:avLst/>
@@ -8911,7 +8929,7 @@
         <p:spPr>
           <a:xfrm>
             <a:off x="0" y="0"/>
-            <a:ext cx="12188160" cy="227880"/>
+            <a:ext cx="12187800" cy="227520"/>
           </a:xfrm>
           <a:prstGeom prst="rect">
             <a:avLst/>
@@ -8973,7 +8991,7 @@
         <p:spPr>
           <a:xfrm>
             <a:off x="0" y="6656760"/>
-            <a:ext cx="12188160" cy="200520"/>
+            <a:ext cx="12187800" cy="200160"/>
           </a:xfrm>
           <a:prstGeom prst="rect">
             <a:avLst/>
@@ -9035,7 +9053,7 @@
         <p:spPr>
           <a:xfrm>
             <a:off x="0" y="228600"/>
-            <a:ext cx="136440" cy="6400080"/>
+            <a:ext cx="136080" cy="6399720"/>
           </a:xfrm>
           <a:prstGeom prst="rect">
             <a:avLst/>
@@ -9150,7 +9168,7 @@
         <p:spPr>
           <a:xfrm>
             <a:off x="1038600" y="864000"/>
-            <a:ext cx="7061040" cy="4903560"/>
+            <a:ext cx="7060680" cy="4934520"/>
           </a:xfrm>
           <a:prstGeom prst="rect">
             <a:avLst/>
@@ -9209,16 +9227,7 @@
                 <a:latin typeface="Arial"/>
                 <a:ea typeface="Noto Sans CJK SC"/>
               </a:rPr>
-              <a:t>2. </a:t>
-            </a:r>
-            <a:r>
-              <a:rPr b="0" lang="en-US" sz="2600" spc="-1" strike="noStrike">
-                <a:solidFill>
-                  <a:srgbClr val="00285a"/>
-                </a:solidFill>
-                <a:latin typeface="Arial"/>
-              </a:rPr>
-              <a:t>Categoria Learn, morfismos e composição</a:t>
+              <a:t>2. Categoria Learn, morfismos e composição</a:t>
             </a:r>
             <a:endParaRPr b="0" lang="pt-BR" sz="2600" spc="-1" strike="noStrike">
               <a:solidFill>
@@ -9241,6 +9250,11 @@
             </a:endParaRPr>
           </a:p>
           <a:p>
+            <a:pPr defTabSz="457200">
+              <a:lnSpc>
+                <a:spcPct val="100000"/>
+              </a:lnSpc>
+            </a:pPr>
             <a:r>
               <a:rPr b="0" lang="en-US" sz="2800" spc="-1" strike="noStrike">
                 <a:solidFill>
@@ -9272,7 +9286,7 @@
               <a:t>L</a:t>
             </a:r>
             <a:br>
-              <a:rPr sz="2600"/>
+              <a:rPr sz="2800"/>
             </a:br>
             <a:endParaRPr b="0" lang="pt-BR" sz="2800" spc="-1" strike="noStrike">
               <a:solidFill>
@@ -9282,12 +9296,18 @@
             </a:endParaRPr>
           </a:p>
           <a:p>
+            <a:pPr defTabSz="457200">
+              <a:lnSpc>
+                <a:spcPct val="100000"/>
+              </a:lnSpc>
+            </a:pPr>
             <a:r>
               <a:rPr b="0" lang="en-US" sz="2600" spc="-1" strike="noStrike">
                 <a:solidFill>
                   <a:srgbClr val="00285a"/>
                 </a:solidFill>
                 <a:latin typeface="Arial"/>
+                <a:ea typeface="MathJax_Caligraphic"/>
               </a:rPr>
               <a:t>3. Implementação em Haskell</a:t>
             </a:r>
@@ -9299,6 +9319,11 @@
             </a:endParaRPr>
           </a:p>
           <a:p>
+            <a:pPr defTabSz="457200">
+              <a:lnSpc>
+                <a:spcPct val="100000"/>
+              </a:lnSpc>
+            </a:pPr>
             <a:br>
               <a:rPr sz="2600"/>
             </a:br>
@@ -9308,6 +9333,7 @@
                   <a:srgbClr val="00285a"/>
                 </a:solidFill>
                 <a:latin typeface="Arial"/>
+                <a:ea typeface="MathJax_Caligraphic"/>
               </a:rPr>
               <a:t>4. Modelos</a:t>
             </a:r>
@@ -9319,6 +9345,11 @@
             </a:endParaRPr>
           </a:p>
           <a:p>
+            <a:pPr defTabSz="457200">
+              <a:lnSpc>
+                <a:spcPct val="100000"/>
+              </a:lnSpc>
+            </a:pPr>
             <a:br>
               <a:rPr sz="2600"/>
             </a:br>
@@ -9328,6 +9359,7 @@
                   <a:srgbClr val="00285a"/>
                 </a:solidFill>
                 <a:latin typeface="Arial"/>
+                <a:ea typeface="MathJax_Caligraphic"/>
               </a:rPr>
               <a:t>5. Conclusões</a:t>
             </a:r>
@@ -9353,7 +9385,7 @@
         <p:spPr>
           <a:xfrm>
             <a:off x="8349480" y="376200"/>
-            <a:ext cx="3838680" cy="2554560"/>
+            <a:ext cx="3838320" cy="2554200"/>
           </a:xfrm>
           <a:prstGeom prst="rect">
             <a:avLst/>
@@ -9376,7 +9408,7 @@
         <p:spPr>
           <a:xfrm>
             <a:off x="9533160" y="3079080"/>
-            <a:ext cx="2513880" cy="1324080"/>
+            <a:ext cx="2513520" cy="1323720"/>
           </a:xfrm>
           <a:prstGeom prst="rect">
             <a:avLst/>
@@ -9399,7 +9431,7 @@
         <p:spPr>
           <a:xfrm>
             <a:off x="8718120" y="5294520"/>
-            <a:ext cx="3709800" cy="1518120"/>
+            <a:ext cx="3709440" cy="1517760"/>
           </a:xfrm>
           <a:prstGeom prst="rect">
             <a:avLst/>
@@ -9428,7 +9460,7 @@
         <p:spPr>
           <a:xfrm>
             <a:off x="10223280" y="4479120"/>
-            <a:ext cx="1667880" cy="1099440"/>
+            <a:ext cx="1667520" cy="1099080"/>
           </a:xfrm>
           <a:prstGeom prst="rect">
             <a:avLst/>
@@ -9484,7 +9516,7 @@
         <p:spPr>
           <a:xfrm>
             <a:off x="0" y="0"/>
-            <a:ext cx="12188160" cy="227880"/>
+            <a:ext cx="12187800" cy="227520"/>
           </a:xfrm>
           <a:prstGeom prst="rect">
             <a:avLst/>
@@ -9546,7 +9578,7 @@
         <p:spPr>
           <a:xfrm>
             <a:off x="0" y="6656760"/>
-            <a:ext cx="12188160" cy="200520"/>
+            <a:ext cx="12187800" cy="200160"/>
           </a:xfrm>
           <a:prstGeom prst="rect">
             <a:avLst/>
@@ -9608,7 +9640,7 @@
         <p:spPr>
           <a:xfrm>
             <a:off x="0" y="228600"/>
-            <a:ext cx="136440" cy="6400080"/>
+            <a:ext cx="136080" cy="6399720"/>
           </a:xfrm>
           <a:prstGeom prst="rect">
             <a:avLst/>
@@ -9670,7 +9702,7 @@
         <p:spPr>
           <a:xfrm>
             <a:off x="640080" y="1280160"/>
-            <a:ext cx="9027720" cy="4730040"/>
+            <a:ext cx="9027360" cy="4729680"/>
           </a:xfrm>
           <a:prstGeom prst="roundRect">
             <a:avLst>
@@ -9734,7 +9766,7 @@
         <p:spPr>
           <a:xfrm>
             <a:off x="914400" y="1645920"/>
-            <a:ext cx="7958880" cy="2099520"/>
+            <a:ext cx="7958520" cy="2099160"/>
           </a:xfrm>
           <a:prstGeom prst="rect">
             <a:avLst/>
@@ -9782,7 +9814,7 @@
         <p:spPr>
           <a:xfrm>
             <a:off x="10013760" y="330480"/>
-            <a:ext cx="2136600" cy="1421640"/>
+            <a:ext cx="2136240" cy="1421280"/>
           </a:xfrm>
           <a:prstGeom prst="rect">
             <a:avLst/>
@@ -9805,7 +9837,7 @@
         <p:spPr>
           <a:xfrm>
             <a:off x="9668520" y="5452200"/>
-            <a:ext cx="2626560" cy="1074600"/>
+            <a:ext cx="2626200" cy="1074240"/>
           </a:xfrm>
           <a:prstGeom prst="rect">
             <a:avLst/>
@@ -9828,7 +9860,7 @@
         <p:spPr>
           <a:xfrm>
             <a:off x="10118880" y="2329560"/>
-            <a:ext cx="2031120" cy="1069920"/>
+            <a:ext cx="2030760" cy="1069560"/>
           </a:xfrm>
           <a:prstGeom prst="rect">
             <a:avLst/>
@@ -9857,7 +9889,7 @@
         <p:spPr>
           <a:xfrm>
             <a:off x="10577160" y="3787560"/>
-            <a:ext cx="1393920" cy="1043280"/>
+            <a:ext cx="1393560" cy="1042920"/>
           </a:xfrm>
           <a:prstGeom prst="rect">
             <a:avLst/>
@@ -9880,7 +9912,7 @@
         <p:spPr>
           <a:xfrm>
             <a:off x="900000" y="2160000"/>
-            <a:ext cx="8565120" cy="3144600"/>
+            <a:ext cx="8564760" cy="3144240"/>
           </a:xfrm>
           <a:prstGeom prst="rect">
             <a:avLst/>
@@ -9995,7 +10027,7 @@
         <p:spPr>
           <a:xfrm>
             <a:off x="0" y="0"/>
-            <a:ext cx="12188160" cy="227880"/>
+            <a:ext cx="12187800" cy="227520"/>
           </a:xfrm>
           <a:prstGeom prst="rect">
             <a:avLst/>
@@ -10057,7 +10089,7 @@
         <p:spPr>
           <a:xfrm>
             <a:off x="0" y="6656760"/>
-            <a:ext cx="12188160" cy="200520"/>
+            <a:ext cx="12187800" cy="200160"/>
           </a:xfrm>
           <a:prstGeom prst="rect">
             <a:avLst/>
@@ -10119,7 +10151,7 @@
         <p:spPr>
           <a:xfrm>
             <a:off x="0" y="228600"/>
-            <a:ext cx="136440" cy="6400080"/>
+            <a:ext cx="136080" cy="6399720"/>
           </a:xfrm>
           <a:prstGeom prst="rect">
             <a:avLst/>
@@ -10234,7 +10266,7 @@
         <p:spPr>
           <a:xfrm>
             <a:off x="548640" y="1411560"/>
-            <a:ext cx="9119160" cy="4479840"/>
+            <a:ext cx="9118800" cy="4479480"/>
           </a:xfrm>
           <a:prstGeom prst="roundRect">
             <a:avLst>
@@ -10302,7 +10334,7 @@
         <p:spPr>
           <a:xfrm>
             <a:off x="10013760" y="330480"/>
-            <a:ext cx="2136600" cy="1421640"/>
+            <a:ext cx="2136240" cy="1421280"/>
           </a:xfrm>
           <a:prstGeom prst="rect">
             <a:avLst/>
@@ -10325,7 +10357,7 @@
         <p:spPr>
           <a:xfrm>
             <a:off x="10118880" y="2329560"/>
-            <a:ext cx="2031120" cy="1069920"/>
+            <a:ext cx="2030760" cy="1069560"/>
           </a:xfrm>
           <a:prstGeom prst="rect">
             <a:avLst/>
@@ -10354,7 +10386,7 @@
         <p:spPr>
           <a:xfrm>
             <a:off x="10577160" y="3787560"/>
-            <a:ext cx="1393920" cy="1043280"/>
+            <a:ext cx="1393560" cy="1042920"/>
           </a:xfrm>
           <a:prstGeom prst="rect">
             <a:avLst/>
@@ -10377,7 +10409,7 @@
         <p:spPr>
           <a:xfrm>
             <a:off x="9668520" y="5452200"/>
-            <a:ext cx="2626560" cy="1074600"/>
+            <a:ext cx="2626200" cy="1074240"/>
           </a:xfrm>
           <a:prstGeom prst="rect">
             <a:avLst/>
@@ -10400,7 +10432,7 @@
         <p:spPr>
           <a:xfrm>
             <a:off x="1032480" y="1620000"/>
-            <a:ext cx="8078760" cy="3959640"/>
+            <a:ext cx="8078400" cy="3959280"/>
           </a:xfrm>
           <a:prstGeom prst="rect">
             <a:avLst/>
@@ -10456,7 +10488,7 @@
         <p:spPr>
           <a:xfrm>
             <a:off x="0" y="0"/>
-            <a:ext cx="12188160" cy="227880"/>
+            <a:ext cx="12187800" cy="227520"/>
           </a:xfrm>
           <a:prstGeom prst="rect">
             <a:avLst/>
@@ -10518,7 +10550,7 @@
         <p:spPr>
           <a:xfrm>
             <a:off x="0" y="6656760"/>
-            <a:ext cx="12188160" cy="200520"/>
+            <a:ext cx="12187800" cy="200160"/>
           </a:xfrm>
           <a:prstGeom prst="rect">
             <a:avLst/>
@@ -10580,7 +10612,7 @@
         <p:spPr>
           <a:xfrm>
             <a:off x="0" y="228600"/>
-            <a:ext cx="136440" cy="6400080"/>
+            <a:ext cx="136080" cy="6399720"/>
           </a:xfrm>
           <a:prstGeom prst="rect">
             <a:avLst/>
@@ -10711,7 +10743,7 @@
         <p:spPr>
           <a:xfrm>
             <a:off x="548640" y="1280160"/>
-            <a:ext cx="9344160" cy="4957920"/>
+            <a:ext cx="9343800" cy="4957560"/>
           </a:xfrm>
           <a:prstGeom prst="roundRect">
             <a:avLst>
@@ -10779,7 +10811,7 @@
         <p:spPr>
           <a:xfrm>
             <a:off x="10013760" y="330480"/>
-            <a:ext cx="2136600" cy="1421640"/>
+            <a:ext cx="2136240" cy="1421280"/>
           </a:xfrm>
           <a:prstGeom prst="rect">
             <a:avLst/>
@@ -10802,7 +10834,7 @@
         <p:spPr>
           <a:xfrm>
             <a:off x="10118880" y="2329560"/>
-            <a:ext cx="2031120" cy="1069920"/>
+            <a:ext cx="2030760" cy="1069560"/>
           </a:xfrm>
           <a:prstGeom prst="rect">
             <a:avLst/>
@@ -10831,7 +10863,7 @@
         <p:spPr>
           <a:xfrm>
             <a:off x="10577160" y="3787560"/>
-            <a:ext cx="1393920" cy="1043280"/>
+            <a:ext cx="1393560" cy="1042920"/>
           </a:xfrm>
           <a:prstGeom prst="rect">
             <a:avLst/>
@@ -10854,7 +10886,7 @@
         <p:spPr>
           <a:xfrm>
             <a:off x="9668520" y="5452200"/>
-            <a:ext cx="2626560" cy="1074600"/>
+            <a:ext cx="2626200" cy="1074240"/>
           </a:xfrm>
           <a:prstGeom prst="rect">
             <a:avLst/>
@@ -10877,7 +10909,7 @@
         <p:spPr>
           <a:xfrm>
             <a:off x="848520" y="1800000"/>
-            <a:ext cx="8819640" cy="4081320"/>
+            <a:ext cx="8819280" cy="4080960"/>
           </a:xfrm>
           <a:prstGeom prst="rect">
             <a:avLst/>
@@ -10933,7 +10965,7 @@
         <p:spPr>
           <a:xfrm>
             <a:off x="0" y="0"/>
-            <a:ext cx="12188160" cy="227880"/>
+            <a:ext cx="12187800" cy="227520"/>
           </a:xfrm>
           <a:prstGeom prst="rect">
             <a:avLst/>
@@ -10995,7 +11027,7 @@
         <p:spPr>
           <a:xfrm>
             <a:off x="0" y="6656760"/>
-            <a:ext cx="12188160" cy="200520"/>
+            <a:ext cx="12187800" cy="200160"/>
           </a:xfrm>
           <a:prstGeom prst="rect">
             <a:avLst/>
@@ -11057,7 +11089,7 @@
         <p:spPr>
           <a:xfrm>
             <a:off x="0" y="228600"/>
-            <a:ext cx="136440" cy="6400080"/>
+            <a:ext cx="136080" cy="6399720"/>
           </a:xfrm>
           <a:prstGeom prst="rect">
             <a:avLst/>
@@ -11178,7 +11210,7 @@
         <p:spPr>
           <a:xfrm>
             <a:off x="548640" y="1280160"/>
-            <a:ext cx="9344160" cy="4957920"/>
+            <a:ext cx="9343800" cy="4957560"/>
           </a:xfrm>
           <a:prstGeom prst="roundRect">
             <a:avLst>
@@ -11246,7 +11278,7 @@
         <p:spPr>
           <a:xfrm>
             <a:off x="10013760" y="330480"/>
-            <a:ext cx="2136600" cy="1421640"/>
+            <a:ext cx="2136240" cy="1421280"/>
           </a:xfrm>
           <a:prstGeom prst="rect">
             <a:avLst/>
@@ -11269,7 +11301,7 @@
         <p:spPr>
           <a:xfrm>
             <a:off x="10118880" y="2329560"/>
-            <a:ext cx="2031120" cy="1069920"/>
+            <a:ext cx="2030760" cy="1069560"/>
           </a:xfrm>
           <a:prstGeom prst="rect">
             <a:avLst/>
@@ -11298,7 +11330,7 @@
         <p:spPr>
           <a:xfrm>
             <a:off x="10577160" y="3787560"/>
-            <a:ext cx="1393920" cy="1043280"/>
+            <a:ext cx="1393560" cy="1042920"/>
           </a:xfrm>
           <a:prstGeom prst="rect">
             <a:avLst/>
@@ -11321,7 +11353,7 @@
         <p:spPr>
           <a:xfrm>
             <a:off x="9668520" y="5452200"/>
-            <a:ext cx="2626560" cy="1074600"/>
+            <a:ext cx="2626200" cy="1074240"/>
           </a:xfrm>
           <a:prstGeom prst="rect">
             <a:avLst/>
@@ -11343,8 +11375,8 @@
         </p:blipFill>
         <p:spPr>
           <a:xfrm>
-            <a:off x="676080" y="1836000"/>
-            <a:ext cx="9043560" cy="3913560"/>
+            <a:off x="683280" y="1836000"/>
+            <a:ext cx="9072720" cy="3860640"/>
           </a:xfrm>
           <a:prstGeom prst="rect">
             <a:avLst/>
@@ -11400,7 +11432,7 @@
         <p:spPr>
           <a:xfrm>
             <a:off x="0" y="0"/>
-            <a:ext cx="12188160" cy="227880"/>
+            <a:ext cx="12187800" cy="227520"/>
           </a:xfrm>
           <a:prstGeom prst="rect">
             <a:avLst/>
@@ -11462,7 +11494,7 @@
         <p:spPr>
           <a:xfrm>
             <a:off x="0" y="6656760"/>
-            <a:ext cx="12188160" cy="200520"/>
+            <a:ext cx="12187800" cy="200160"/>
           </a:xfrm>
           <a:prstGeom prst="rect">
             <a:avLst/>
@@ -11524,7 +11556,7 @@
         <p:spPr>
           <a:xfrm>
             <a:off x="0" y="228600"/>
-            <a:ext cx="136440" cy="6400080"/>
+            <a:ext cx="136080" cy="6399720"/>
           </a:xfrm>
           <a:prstGeom prst="rect">
             <a:avLst/>
@@ -11645,7 +11677,7 @@
         <p:spPr>
           <a:xfrm>
             <a:off x="548640" y="1280160"/>
-            <a:ext cx="9344160" cy="4957920"/>
+            <a:ext cx="9343800" cy="4957560"/>
           </a:xfrm>
           <a:prstGeom prst="roundRect">
             <a:avLst>
@@ -11713,7 +11745,7 @@
         <p:spPr>
           <a:xfrm>
             <a:off x="10013760" y="330480"/>
-            <a:ext cx="2136600" cy="1421640"/>
+            <a:ext cx="2136240" cy="1421280"/>
           </a:xfrm>
           <a:prstGeom prst="rect">
             <a:avLst/>
@@ -11736,7 +11768,7 @@
         <p:spPr>
           <a:xfrm>
             <a:off x="10118880" y="2329560"/>
-            <a:ext cx="2031120" cy="1069920"/>
+            <a:ext cx="2030760" cy="1069560"/>
           </a:xfrm>
           <a:prstGeom prst="rect">
             <a:avLst/>
@@ -11765,7 +11797,7 @@
         <p:spPr>
           <a:xfrm>
             <a:off x="10577160" y="3787560"/>
-            <a:ext cx="1393920" cy="1043280"/>
+            <a:ext cx="1393560" cy="1042920"/>
           </a:xfrm>
           <a:prstGeom prst="rect">
             <a:avLst/>
@@ -11788,7 +11820,7 @@
         <p:spPr>
           <a:xfrm>
             <a:off x="9668520" y="5452200"/>
-            <a:ext cx="2626560" cy="1074600"/>
+            <a:ext cx="2626200" cy="1074240"/>
           </a:xfrm>
           <a:prstGeom prst="rect">
             <a:avLst/>
@@ -11810,8 +11842,8 @@
         </p:blipFill>
         <p:spPr>
           <a:xfrm>
-            <a:off x="720000" y="2215440"/>
-            <a:ext cx="8999640" cy="3198960"/>
+            <a:off x="634680" y="2038680"/>
+            <a:ext cx="9193320" cy="3325320"/>
           </a:xfrm>
           <a:prstGeom prst="rect">
             <a:avLst/>
@@ -11867,7 +11899,7 @@
         <p:spPr>
           <a:xfrm>
             <a:off x="0" y="0"/>
-            <a:ext cx="12188160" cy="227880"/>
+            <a:ext cx="12187800" cy="227520"/>
           </a:xfrm>
           <a:prstGeom prst="rect">
             <a:avLst/>
@@ -11929,7 +11961,7 @@
         <p:spPr>
           <a:xfrm>
             <a:off x="0" y="6656760"/>
-            <a:ext cx="12188160" cy="200520"/>
+            <a:ext cx="12187800" cy="200160"/>
           </a:xfrm>
           <a:prstGeom prst="rect">
             <a:avLst/>
@@ -11991,7 +12023,7 @@
         <p:spPr>
           <a:xfrm>
             <a:off x="0" y="228600"/>
-            <a:ext cx="136440" cy="6400080"/>
+            <a:ext cx="136080" cy="6399720"/>
           </a:xfrm>
           <a:prstGeom prst="rect">
             <a:avLst/>
@@ -12112,7 +12144,7 @@
         <p:spPr>
           <a:xfrm>
             <a:off x="548640" y="1280160"/>
-            <a:ext cx="9344160" cy="4957920"/>
+            <a:ext cx="9343800" cy="4957560"/>
           </a:xfrm>
           <a:prstGeom prst="roundRect">
             <a:avLst>
@@ -12180,7 +12212,7 @@
         <p:spPr>
           <a:xfrm>
             <a:off x="10013760" y="330480"/>
-            <a:ext cx="2136600" cy="1421640"/>
+            <a:ext cx="2136240" cy="1421280"/>
           </a:xfrm>
           <a:prstGeom prst="rect">
             <a:avLst/>
@@ -12203,7 +12235,7 @@
         <p:spPr>
           <a:xfrm>
             <a:off x="10118880" y="2329560"/>
-            <a:ext cx="2031120" cy="1069920"/>
+            <a:ext cx="2030760" cy="1069560"/>
           </a:xfrm>
           <a:prstGeom prst="rect">
             <a:avLst/>
@@ -12232,7 +12264,7 @@
         <p:spPr>
           <a:xfrm>
             <a:off x="10577160" y="3787560"/>
-            <a:ext cx="1393920" cy="1043280"/>
+            <a:ext cx="1393560" cy="1042920"/>
           </a:xfrm>
           <a:prstGeom prst="rect">
             <a:avLst/>
@@ -12255,7 +12287,7 @@
         <p:spPr>
           <a:xfrm>
             <a:off x="9668520" y="5452200"/>
-            <a:ext cx="2626560" cy="1074600"/>
+            <a:ext cx="2626200" cy="1074240"/>
           </a:xfrm>
           <a:prstGeom prst="rect">
             <a:avLst/>
@@ -12278,7 +12310,7 @@
         <p:spPr>
           <a:xfrm>
             <a:off x="892800" y="1620000"/>
-            <a:ext cx="8646840" cy="4240440"/>
+            <a:ext cx="8646480" cy="4240080"/>
           </a:xfrm>
           <a:prstGeom prst="rect">
             <a:avLst/>
@@ -12334,7 +12366,7 @@
         <p:spPr>
           <a:xfrm>
             <a:off x="0" y="0"/>
-            <a:ext cx="12188160" cy="227880"/>
+            <a:ext cx="12187800" cy="227520"/>
           </a:xfrm>
           <a:prstGeom prst="rect">
             <a:avLst/>
@@ -12396,7 +12428,7 @@
         <p:spPr>
           <a:xfrm>
             <a:off x="0" y="6656760"/>
-            <a:ext cx="12188160" cy="200520"/>
+            <a:ext cx="12187800" cy="200160"/>
           </a:xfrm>
           <a:prstGeom prst="rect">
             <a:avLst/>
@@ -12458,7 +12490,7 @@
         <p:spPr>
           <a:xfrm>
             <a:off x="0" y="228600"/>
-            <a:ext cx="136440" cy="6400080"/>
+            <a:ext cx="136080" cy="6399720"/>
           </a:xfrm>
           <a:prstGeom prst="rect">
             <a:avLst/>
@@ -12579,7 +12611,7 @@
         <p:spPr>
           <a:xfrm>
             <a:off x="548640" y="1280160"/>
-            <a:ext cx="9344160" cy="4957920"/>
+            <a:ext cx="9343800" cy="4957560"/>
           </a:xfrm>
           <a:prstGeom prst="roundRect">
             <a:avLst>
@@ -12647,7 +12679,7 @@
         <p:spPr>
           <a:xfrm>
             <a:off x="10013760" y="330480"/>
-            <a:ext cx="2136600" cy="1421640"/>
+            <a:ext cx="2136240" cy="1421280"/>
           </a:xfrm>
           <a:prstGeom prst="rect">
             <a:avLst/>
@@ -12670,7 +12702,7 @@
         <p:spPr>
           <a:xfrm>
             <a:off x="10118880" y="2329560"/>
-            <a:ext cx="2031120" cy="1069920"/>
+            <a:ext cx="2030760" cy="1069560"/>
           </a:xfrm>
           <a:prstGeom prst="rect">
             <a:avLst/>
@@ -12699,7 +12731,7 @@
         <p:spPr>
           <a:xfrm>
             <a:off x="10577160" y="3787560"/>
-            <a:ext cx="1393920" cy="1043280"/>
+            <a:ext cx="1393560" cy="1042920"/>
           </a:xfrm>
           <a:prstGeom prst="rect">
             <a:avLst/>
@@ -12722,7 +12754,7 @@
         <p:spPr>
           <a:xfrm>
             <a:off x="9668520" y="5452200"/>
-            <a:ext cx="2626560" cy="1074600"/>
+            <a:ext cx="2626200" cy="1074240"/>
           </a:xfrm>
           <a:prstGeom prst="rect">
             <a:avLst/>
@@ -12745,7 +12777,7 @@
         <p:spPr>
           <a:xfrm>
             <a:off x="900000" y="1620000"/>
-            <a:ext cx="8722080" cy="4319640"/>
+            <a:ext cx="8721720" cy="4319280"/>
           </a:xfrm>
           <a:prstGeom prst="rect">
             <a:avLst/>

</xml_diff>